<commit_message>
fix changes on 2025-01-21
</commit_message>
<xml_diff>
--- a/Analytics/00-1 Остновы статистики ЦПТ/Presentation/00-1 Intro in statistics.pptx
+++ b/Analytics/00-1 Остновы статистики ЦПТ/Presentation/00-1 Intro in statistics.pptx
@@ -251,7 +251,7 @@
           <a:p>
             <a:fld id="{929D4DEE-AA18-4B6A-845C-60AFD9463AA2}" type="datetimeFigureOut">
               <a:rPr lang="ru-RU" smtClean="0"/>
-              <a:t>19.10.2024</a:t>
+              <a:t>12.01.2025</a:t>
             </a:fld>
             <a:endParaRPr lang="ru-RU"/>
           </a:p>
@@ -2672,7 +2672,7 @@
           <a:p>
             <a:fld id="{1D8BD707-D9CF-40AE-B4C6-C98DA3205C09}" type="datetimeFigureOut">
               <a:rPr lang="en-US"/>
-              <a:t>10/19/24</a:t>
+              <a:t>1/12/25</a:t>
             </a:fld>
             <a:endParaRPr lang="en-US"/>
           </a:p>
@@ -2847,7 +2847,7 @@
           <a:p>
             <a:fld id="{1D8BD707-D9CF-40AE-B4C6-C98DA3205C09}" type="datetimeFigureOut">
               <a:rPr lang="en-US"/>
-              <a:t>10/19/24</a:t>
+              <a:t>1/12/25</a:t>
             </a:fld>
             <a:endParaRPr lang="en-US"/>
           </a:p>
@@ -3103,7 +3103,7 @@
           <a:p>
             <a:fld id="{1D8BD707-D9CF-40AE-B4C6-C98DA3205C09}" type="datetimeFigureOut">
               <a:rPr lang="en-US"/>
-              <a:t>10/19/24</a:t>
+              <a:t>1/12/25</a:t>
             </a:fld>
             <a:endParaRPr lang="en-US"/>
           </a:p>
@@ -3281,7 +3281,7 @@
           <a:p>
             <a:fld id="{1D8BD707-D9CF-40AE-B4C6-C98DA3205C09}" type="datetimeFigureOut">
               <a:rPr lang="en-US"/>
-              <a:t>10/19/24</a:t>
+              <a:t>1/12/25</a:t>
             </a:fld>
             <a:endParaRPr lang="en-US"/>
           </a:p>
@@ -3400,7 +3400,7 @@
           <a:p>
             <a:fld id="{1D8BD707-D9CF-40AE-B4C6-C98DA3205C09}" type="datetimeFigureOut">
               <a:rPr lang="en-US"/>
-              <a:t>10/19/24</a:t>
+              <a:t>1/12/25</a:t>
             </a:fld>
             <a:endParaRPr lang="en-US"/>
           </a:p>
@@ -6101,7 +6101,7 @@
           <a:p>
             <a:fld id="{1D8BD707-D9CF-40AE-B4C6-C98DA3205C09}" type="datetimeFigureOut">
               <a:rPr lang="en-US"/>
-              <a:t>10/19/24</a:t>
+              <a:t>1/12/25</a:t>
             </a:fld>
             <a:endParaRPr lang="en-US"/>
           </a:p>
@@ -17452,16 +17452,14 @@
         </p:nvSpPr>
         <p:spPr>
           <a:xfrm>
-            <a:off x="5045557" y="2671225"/>
-            <a:ext cx="3159080" cy="680465"/>
+            <a:off x="702838" y="2715668"/>
+            <a:ext cx="3029815" cy="680465"/>
           </a:xfrm>
           <a:prstGeom prst="roundRect">
             <a:avLst/>
           </a:prstGeom>
           <a:solidFill>
-            <a:schemeClr val="bg1">
-              <a:lumMod val="95000"/>
-            </a:schemeClr>
+            <a:srgbClr val="FFD966"/>
           </a:solidFill>
           <a:ln>
             <a:noFill/>
@@ -17489,66 +17487,55 @@
           <a:p>
             <a:pPr algn="ctr"/>
             <a:r>
-              <a:rPr lang="ru-RU" sz="1400" spc="-20" dirty="0">
+              <a:rPr lang="ru-RU" sz="1400" dirty="0">
                 <a:solidFill>
-                  <a:schemeClr val="tx1">
-                    <a:lumMod val="50000"/>
-                    <a:lumOff val="50000"/>
-                  </a:schemeClr>
+                  <a:schemeClr val="tx1"/>
                 </a:solidFill>
-                <a:latin typeface="Roboto"/>
-                <a:cs typeface="Roboto"/>
+                <a:latin typeface="roboto" panose="02000000000000000000" pitchFamily="2" charset="0"/>
               </a:rPr>
               <a:t>Работа с базами данных, </a:t>
             </a:r>
             <a:br>
-              <a:rPr lang="ru-RU" sz="1400" spc="-20" dirty="0">
+              <a:rPr lang="ru-RU" sz="1400">
                 <a:solidFill>
-                  <a:schemeClr val="tx1">
-                    <a:lumMod val="50000"/>
-                    <a:lumOff val="50000"/>
-                  </a:schemeClr>
+                  <a:schemeClr val="tx1"/>
                 </a:solidFill>
-                <a:latin typeface="Roboto"/>
-                <a:cs typeface="Roboto"/>
+                <a:latin typeface="roboto" panose="02000000000000000000" pitchFamily="2" charset="0"/>
               </a:rPr>
             </a:br>
             <a:r>
-              <a:rPr lang="ru-RU" sz="1400" spc="-20" dirty="0" err="1">
+              <a:rPr lang="ru-RU" sz="1400">
                 <a:solidFill>
-                  <a:schemeClr val="tx1">
-                    <a:lumMod val="50000"/>
-                    <a:lumOff val="50000"/>
-                  </a:schemeClr>
+                  <a:schemeClr val="tx1"/>
                 </a:solidFill>
-                <a:latin typeface="Roboto"/>
-                <a:cs typeface="Roboto"/>
+                <a:latin typeface="roboto" panose="02000000000000000000" pitchFamily="2" charset="0"/>
               </a:rPr>
               <a:t>парсинг</a:t>
             </a:r>
             <a:r>
-              <a:rPr lang="ru-RU" sz="1400" spc="-20" dirty="0">
+              <a:rPr lang="ru-RU" sz="1400" dirty="0">
                 <a:solidFill>
-                  <a:schemeClr val="tx1">
-                    <a:lumMod val="50000"/>
-                    <a:lumOff val="50000"/>
-                  </a:schemeClr>
+                  <a:schemeClr val="tx1"/>
                 </a:solidFill>
-                <a:latin typeface="Roboto"/>
-                <a:cs typeface="Roboto"/>
+                <a:latin typeface="roboto" panose="02000000000000000000" pitchFamily="2" charset="0"/>
               </a:rPr>
-              <a:t> данных с сайтов, взаимодействие с </a:t>
-            </a:r>
-            <a:r>
-              <a:rPr lang="en-US" sz="1400" spc="-20" dirty="0">
+              <a:t> данных с сайтов, взаимодействие </a:t>
+            </a:r>
+            <a:r>
+              <a:rPr lang="ru-RU" sz="1400">
                 <a:solidFill>
-                  <a:schemeClr val="tx1">
-                    <a:lumMod val="50000"/>
-                    <a:lumOff val="50000"/>
-                  </a:schemeClr>
+                  <a:schemeClr val="tx1"/>
                 </a:solidFill>
-                <a:latin typeface="Roboto"/>
-                <a:cs typeface="Roboto"/>
+                <a:latin typeface="roboto" panose="02000000000000000000" pitchFamily="2" charset="0"/>
+              </a:rPr>
+              <a:t>с </a:t>
+            </a:r>
+            <a:r>
+              <a:rPr lang="en-US" sz="1400" dirty="0">
+                <a:solidFill>
+                  <a:schemeClr val="tx1"/>
+                </a:solidFill>
+                <a:latin typeface="roboto" panose="02000000000000000000" pitchFamily="2" charset="0"/>
               </a:rPr>
               <a:t>API</a:t>
             </a:r>
@@ -17745,15 +17732,15 @@
           </p:cNvPr>
           <p:cNvCxnSpPr>
             <a:cxnSpLocks/>
-            <a:stCxn id="31" idx="0"/>
+            <a:stCxn id="18" idx="0"/>
             <a:endCxn id="28" idx="2"/>
           </p:cNvCxnSpPr>
           <p:nvPr/>
         </p:nvCxnSpPr>
         <p:spPr>
           <a:xfrm rot="16200000" flipV="1">
-            <a:off x="4132441" y="178569"/>
-            <a:ext cx="786475" cy="4198838"/>
+            <a:off x="4167192" y="143817"/>
+            <a:ext cx="595050" cy="4076916"/>
           </a:xfrm>
           <a:prstGeom prst="curvedConnector3">
             <a:avLst>
@@ -17796,40 +17783,32 @@
           </p:cNvPr>
           <p:cNvCxnSpPr>
             <a:cxnSpLocks/>
-            <a:stCxn id="31" idx="1"/>
-            <a:endCxn id="18" idx="3"/>
+            <a:stCxn id="31" idx="3"/>
+            <a:endCxn id="18" idx="1"/>
           </p:cNvCxnSpPr>
           <p:nvPr/>
         </p:nvCxnSpPr>
         <p:spPr>
-          <a:xfrm rot="10800000" flipV="1">
-            <a:off x="3732655" y="3011457"/>
-            <a:ext cx="1312902" cy="18239"/>
+          <a:xfrm flipV="1">
+            <a:off x="3732653" y="2820033"/>
+            <a:ext cx="1255613" cy="235868"/>
           </a:xfrm>
           <a:prstGeom prst="curvedConnector3">
             <a:avLst>
               <a:gd name="adj1" fmla="val 50000"/>
             </a:avLst>
           </a:prstGeom>
-          <a:ln w="12700">
-            <a:solidFill>
-              <a:schemeClr val="tx1">
-                <a:lumMod val="50000"/>
-                <a:lumOff val="50000"/>
-              </a:schemeClr>
-            </a:solidFill>
-            <a:prstDash val="dash"/>
-          </a:ln>
+          <a:ln/>
         </p:spPr>
         <p:style>
           <a:lnRef idx="1">
-            <a:schemeClr val="accent1"/>
+            <a:schemeClr val="dk1"/>
           </a:lnRef>
           <a:fillRef idx="0">
-            <a:schemeClr val="accent1"/>
+            <a:schemeClr val="dk1"/>
           </a:fillRef>
           <a:effectRef idx="0">
-            <a:schemeClr val="accent1"/>
+            <a:schemeClr val="dk1"/>
           </a:effectRef>
           <a:fontRef idx="minor">
             <a:schemeClr val="tx1"/>
@@ -17897,7 +17876,7 @@
         </p:nvSpPr>
         <p:spPr>
           <a:xfrm>
-            <a:off x="702838" y="2689464"/>
+            <a:off x="4988266" y="2479800"/>
             <a:ext cx="3029817" cy="680465"/>
           </a:xfrm>
           <a:prstGeom prst="roundRect">
@@ -17963,15 +17942,15 @@
           </p:cNvPr>
           <p:cNvCxnSpPr>
             <a:cxnSpLocks/>
-            <a:stCxn id="18" idx="1"/>
+            <a:stCxn id="31" idx="1"/>
             <a:endCxn id="32" idx="1"/>
           </p:cNvCxnSpPr>
           <p:nvPr/>
         </p:nvCxnSpPr>
         <p:spPr>
           <a:xfrm rot="10800000" flipV="1">
-            <a:off x="702838" y="3029697"/>
-            <a:ext cx="1" cy="1101486"/>
+            <a:off x="702838" y="3055901"/>
+            <a:ext cx="1" cy="1075282"/>
           </a:xfrm>
           <a:prstGeom prst="curvedConnector3">
             <a:avLst>

</xml_diff>